<commit_message>
docs: observability layer across the documents and decks
Story US-077, ARCHITECTURE module and API row, OPERATIONS section
with the Railway services and the rollback line, THREAT_MODEL T23,
TEST_STRATEGY, SCOPE C9, readiness row 24 as built, README section;
solution-architecture and deployment views regenerated with the
Prometheus and Grafana additions; both decks rebuilt.
</commit_message>
<xml_diff>
--- a/docs/13-debrief/pitch-deck/PermitFlow-pitch.pptx
+++ b/docs/13-debrief/pitch-deck/PermitFlow-pitch.pptx
@@ -2525,7 +2525,7 @@
                 <a:ea typeface="Public Sans" pitchFamily="34" charset="-122"/>
                 <a:cs typeface="Public Sans" pitchFamily="34" charset="-120"/>
               </a:rPr>
-              <a:t>22</a:t>
+              <a:t>23</a:t>
             </a:r>
             <a:pPr algn="l" indent="0" marL="0">
               <a:lnSpc>
@@ -3577,7 +3577,7 @@
                 <a:ea typeface="Public Sans" pitchFamily="34" charset="-122"/>
                 <a:cs typeface="Public Sans" pitchFamily="34" charset="-120"/>
               </a:rPr>
-              <a:t>Images built once; production behind an approval; health gates after every deploy; request ids everywhere.</a:t>
+              <a:t>Images built once; production behind an approval; health gates after every deploy; request ids everywhere; Prometheus metrics and a Grafana dashboard with six alert rules.</a:t>
             </a:r>
             <a:endParaRPr lang="en-US" sz="1100" dirty="0"/>
           </a:p>
@@ -6203,7 +6203,7 @@
                 <a:ea typeface="Public Sans" pitchFamily="34" charset="-122"/>
                 <a:cs typeface="Public Sans" pitchFamily="34" charset="-120"/>
               </a:rPr>
-              <a:t>Delivery and backups</a:t>
+              <a:t>Delivery, backups and alert routing</a:t>
             </a:r>
             <a:endParaRPr lang="en-US" sz="1200" dirty="0"/>
           </a:p>
@@ -6245,7 +6245,7 @@
                 <a:ea typeface="Public Sans" pitchFamily="34" charset="-122"/>
                 <a:cs typeface="Public Sans" pitchFamily="34" charset="-120"/>
               </a:rPr>
-              <a:t>Scheduled backups with a tested restore; a staging rehearsal for migrations; image scanning.</a:t>
+              <a:t>Scheduled backups with a tested restore; a staging rehearsal for migrations; image scanning; alerts routed to a channel, exporters for nginx and Postgres.</a:t>
             </a:r>
             <a:endParaRPr lang="en-US" sz="1000" dirty="0"/>
           </a:p>
@@ -28616,7 +28616,7 @@
                 <a:ea typeface="Public Sans" pitchFamily="34" charset="-122"/>
                 <a:cs typeface="Public Sans" pitchFamily="34" charset="-120"/>
               </a:rPr>
-              <a:t>LangSmith</a:t>
+              <a:t>LangSmith · Prometheus · Grafana</a:t>
             </a:r>
             <a:endParaRPr lang="en-US" sz="1150" dirty="0"/>
           </a:p>
@@ -28658,7 +28658,7 @@
                 <a:ea typeface="Public Sans" pitchFamily="34" charset="-122"/>
                 <a:cs typeface="Public Sans" pitchFamily="34" charset="-120"/>
               </a:rPr>
-              <a:t>AI traces with inputs hidden</a:t>
+              <a:t>AI traces with inputs hidden; metrics behind a token, one dashboard, six alert rules</a:t>
             </a:r>
             <a:endParaRPr lang="en-US" sz="1000" dirty="0"/>
           </a:p>

</xml_diff>